<commit_message>
Update INARA 2026-09-03 17:09:00
</commit_message>
<xml_diff>
--- a/reports/BRANCH_DENPASAR_PERFORMANCE_SUMMARY_20260902_INARA.pptx
+++ b/reports/BRANCH_DENPASAR_PERFORMANCE_SUMMARY_20260902_INARA.pptx
@@ -13627,7 +13627,7 @@
                 </a:solidFill>
                 <a:latin typeface="Arial"/>
               </a:rPr>
-              <a:t>39</a:t>
+              <a:t>40</a:t>
             </a:r>
           </a:p>
         </p:txBody>
@@ -13658,11 +13658,11 @@
             <a:r>
               <a:rPr sz="1200" b="1" i="0">
                 <a:solidFill>
-                  <a:srgbClr val="D73527"/>
+                  <a:srgbClr val="137D3F"/>
                 </a:solidFill>
                 <a:latin typeface="Arial"/>
               </a:rPr>
-              <a:t>-82,3%</a:t>
+              <a:t>+1233,3%</a:t>
             </a:r>
           </a:p>
         </p:txBody>
@@ -13697,7 +13697,7 @@
                 </a:solidFill>
                 <a:latin typeface="Arial"/>
               </a:rPr>
-              <a:t>MTD-1: 220   Δ -181</a:t>
+              <a:t>MTD-1: 3   Δ 37</a:t>
             </a:r>
           </a:p>
         </p:txBody>
@@ -13814,7 +13814,7 @@
                 </a:solidFill>
                 <a:latin typeface="Arial"/>
               </a:rPr>
-              <a:t>416</a:t>
+              <a:t>438</a:t>
             </a:r>
           </a:p>
         </p:txBody>
@@ -13845,11 +13845,11 @@
             <a:r>
               <a:rPr sz="1200" b="1" i="0">
                 <a:solidFill>
-                  <a:srgbClr val="D73527"/>
+                  <a:srgbClr val="137D3F"/>
                 </a:solidFill>
                 <a:latin typeface="Arial"/>
               </a:rPr>
-              <a:t>-93,5%</a:t>
+              <a:t>+10850,0%</a:t>
             </a:r>
           </a:p>
         </p:txBody>
@@ -13884,7 +13884,7 @@
                 </a:solidFill>
                 <a:latin typeface="Arial"/>
               </a:rPr>
-              <a:t>MTD-1: 6.435   Δ -6.019</a:t>
+              <a:t>MTD-1: 4   Δ 434</a:t>
             </a:r>
           </a:p>
         </p:txBody>
@@ -15020,7 +15020,7 @@
                           </a:solidFill>
                           <a:latin typeface="Arial"/>
                         </a:rPr>
-                        <a:t>54</a:t>
+                        <a:t>3</a:t>
                       </a:r>
                     </a:p>
                   </a:txBody>
@@ -15110,17 +15110,17 @@
                       <a:r>
                         <a:rPr sz="1050" b="0">
                           <a:solidFill>
-                            <a:srgbClr val="D73527"/>
-                          </a:solidFill>
-                          <a:latin typeface="Arial"/>
-                        </a:rPr>
-                        <a:t>-92,6%</a:t>
-                      </a:r>
-                    </a:p>
-                  </a:txBody>
-                  <a:tcPr marL="27432" marR="27432" marT="0" marB="0">
-                    <a:solidFill>
-                      <a:srgbClr val="FBE9E7"/>
+                            <a:srgbClr val="137D3F"/>
+                          </a:solidFill>
+                          <a:latin typeface="Arial"/>
+                        </a:rPr>
+                        <a:t>+33,3%</a:t>
+                      </a:r>
+                    </a:p>
+                  </a:txBody>
+                  <a:tcPr marL="27432" marR="27432" marT="0" marB="0">
+                    <a:solidFill>
+                      <a:srgbClr val="E5F4EA"/>
                     </a:solidFill>
                     <a:lnL w="9000" cap="flat" cmpd="sng" algn="ctr">
                       <a:solidFill>
@@ -15161,7 +15161,7 @@
                           </a:solidFill>
                           <a:latin typeface="Arial"/>
                         </a:rPr>
-                        <a:t>1.339</a:t>
+                        <a:t>4</a:t>
                       </a:r>
                     </a:p>
                   </a:txBody>
@@ -15251,17 +15251,17 @@
                       <a:r>
                         <a:rPr sz="1050" b="0">
                           <a:solidFill>
-                            <a:srgbClr val="D73527"/>
-                          </a:solidFill>
-                          <a:latin typeface="Arial"/>
-                        </a:rPr>
-                        <a:t>-98,0%</a:t>
-                      </a:r>
-                    </a:p>
-                  </a:txBody>
-                  <a:tcPr marL="27432" marR="27432" marT="0" marB="0">
-                    <a:solidFill>
-                      <a:srgbClr val="FBE9E7"/>
+                            <a:srgbClr val="137D3F"/>
+                          </a:solidFill>
+                          <a:latin typeface="Arial"/>
+                        </a:rPr>
+                        <a:t>+575,0%</a:t>
+                      </a:r>
+                    </a:p>
+                  </a:txBody>
+                  <a:tcPr marL="27432" marR="27432" marT="0" marB="0">
+                    <a:solidFill>
+                      <a:srgbClr val="E5F4EA"/>
                     </a:solidFill>
                     <a:lnL w="9000" cap="flat" cmpd="sng" algn="ctr">
                       <a:solidFill>
@@ -15680,7 +15680,7 @@
                           </a:solidFill>
                           <a:latin typeface="Arial"/>
                         </a:rPr>
-                        <a:t>84</a:t>
+                        <a:t>0</a:t>
                       </a:r>
                     </a:p>
                   </a:txBody>
@@ -15770,17 +15770,17 @@
                       <a:r>
                         <a:rPr sz="1050" b="0">
                           <a:solidFill>
-                            <a:srgbClr val="D73527"/>
-                          </a:solidFill>
-                          <a:latin typeface="Arial"/>
-                        </a:rPr>
-                        <a:t>-78,6%</a:t>
-                      </a:r>
-                    </a:p>
-                  </a:txBody>
-                  <a:tcPr marL="27432" marR="27432" marT="0" marB="0">
-                    <a:solidFill>
-                      <a:srgbClr val="FBE9E7"/>
+                            <a:srgbClr val="687386"/>
+                          </a:solidFill>
+                          <a:latin typeface="Arial"/>
+                        </a:rPr>
+                        <a:t>N/A</a:t>
+                      </a:r>
+                    </a:p>
+                  </a:txBody>
+                  <a:tcPr marL="27432" marR="27432" marT="0" marB="0">
+                    <a:solidFill>
+                      <a:srgbClr val="E9EDF2"/>
                     </a:solidFill>
                     <a:lnL w="9000" cap="flat" cmpd="sng" algn="ctr">
                       <a:solidFill>
@@ -15821,7 +15821,7 @@
                           </a:solidFill>
                           <a:latin typeface="Arial"/>
                         </a:rPr>
-                        <a:t>1.998</a:t>
+                        <a:t>0</a:t>
                       </a:r>
                     </a:p>
                   </a:txBody>
@@ -15868,7 +15868,7 @@
                           </a:solidFill>
                           <a:latin typeface="Arial"/>
                         </a:rPr>
-                        <a:t>125</a:t>
+                        <a:t>129</a:t>
                       </a:r>
                     </a:p>
                   </a:txBody>
@@ -15911,17 +15911,17 @@
                       <a:r>
                         <a:rPr sz="1050" b="0">
                           <a:solidFill>
-                            <a:srgbClr val="D73527"/>
-                          </a:solidFill>
-                          <a:latin typeface="Arial"/>
-                        </a:rPr>
-                        <a:t>-93,7%</a:t>
-                      </a:r>
-                    </a:p>
-                  </a:txBody>
-                  <a:tcPr marL="27432" marR="27432" marT="0" marB="0">
-                    <a:solidFill>
-                      <a:srgbClr val="FBE9E7"/>
+                            <a:srgbClr val="687386"/>
+                          </a:solidFill>
+                          <a:latin typeface="Arial"/>
+                        </a:rPr>
+                        <a:t>N/A</a:t>
+                      </a:r>
+                    </a:p>
+                  </a:txBody>
+                  <a:tcPr marL="27432" marR="27432" marT="0" marB="0">
+                    <a:solidFill>
+                      <a:srgbClr val="E9EDF2"/>
                     </a:solidFill>
                     <a:lnL w="9000" cap="flat" cmpd="sng" algn="ctr">
                       <a:solidFill>
@@ -16340,7 +16340,7 @@
                           </a:solidFill>
                           <a:latin typeface="Arial"/>
                         </a:rPr>
-                        <a:t>44</a:t>
+                        <a:t>0</a:t>
                       </a:r>
                     </a:p>
                   </a:txBody>
@@ -16387,7 +16387,7 @@
                           </a:solidFill>
                           <a:latin typeface="Arial"/>
                         </a:rPr>
-                        <a:t>13</a:t>
+                        <a:t>14</a:t>
                       </a:r>
                     </a:p>
                   </a:txBody>
@@ -16430,17 +16430,17 @@
                       <a:r>
                         <a:rPr sz="1050" b="0">
                           <a:solidFill>
-                            <a:srgbClr val="D73527"/>
-                          </a:solidFill>
-                          <a:latin typeface="Arial"/>
-                        </a:rPr>
-                        <a:t>-70,5%</a:t>
-                      </a:r>
-                    </a:p>
-                  </a:txBody>
-                  <a:tcPr marL="27432" marR="27432" marT="0" marB="0">
-                    <a:solidFill>
-                      <a:srgbClr val="FBE9E7"/>
+                            <a:srgbClr val="687386"/>
+                          </a:solidFill>
+                          <a:latin typeface="Arial"/>
+                        </a:rPr>
+                        <a:t>N/A</a:t>
+                      </a:r>
+                    </a:p>
+                  </a:txBody>
+                  <a:tcPr marL="27432" marR="27432" marT="0" marB="0">
+                    <a:solidFill>
+                      <a:srgbClr val="E9EDF2"/>
                     </a:solidFill>
                     <a:lnL w="9000" cap="flat" cmpd="sng" algn="ctr">
                       <a:solidFill>
@@ -16481,7 +16481,7 @@
                           </a:solidFill>
                           <a:latin typeface="Arial"/>
                         </a:rPr>
-                        <a:t>1.821</a:t>
+                        <a:t>0</a:t>
                       </a:r>
                     </a:p>
                   </a:txBody>
@@ -16528,7 +16528,7 @@
                           </a:solidFill>
                           <a:latin typeface="Arial"/>
                         </a:rPr>
-                        <a:t>230</a:t>
+                        <a:t>248</a:t>
                       </a:r>
                     </a:p>
                   </a:txBody>
@@ -16571,17 +16571,17 @@
                       <a:r>
                         <a:rPr sz="1050" b="0">
                           <a:solidFill>
-                            <a:srgbClr val="D73527"/>
-                          </a:solidFill>
-                          <a:latin typeface="Arial"/>
-                        </a:rPr>
-                        <a:t>-87,4%</a:t>
-                      </a:r>
-                    </a:p>
-                  </a:txBody>
-                  <a:tcPr marL="27432" marR="27432" marT="0" marB="0">
-                    <a:solidFill>
-                      <a:srgbClr val="FBE9E7"/>
+                            <a:srgbClr val="687386"/>
+                          </a:solidFill>
+                          <a:latin typeface="Arial"/>
+                        </a:rPr>
+                        <a:t>N/A</a:t>
+                      </a:r>
+                    </a:p>
+                  </a:txBody>
+                  <a:tcPr marL="27432" marR="27432" marT="0" marB="0">
+                    <a:solidFill>
+                      <a:srgbClr val="E9EDF2"/>
                     </a:solidFill>
                     <a:lnL w="9000" cap="flat" cmpd="sng" algn="ctr">
                       <a:solidFill>
@@ -17000,7 +17000,7 @@
                           </a:solidFill>
                           <a:latin typeface="Arial"/>
                         </a:rPr>
-                        <a:t>38</a:t>
+                        <a:t>0</a:t>
                       </a:r>
                     </a:p>
                   </a:txBody>
@@ -17090,17 +17090,17 @@
                       <a:r>
                         <a:rPr sz="1050" b="0">
                           <a:solidFill>
-                            <a:srgbClr val="D73527"/>
-                          </a:solidFill>
-                          <a:latin typeface="Arial"/>
-                        </a:rPr>
-                        <a:t>-89,5%</a:t>
-                      </a:r>
-                    </a:p>
-                  </a:txBody>
-                  <a:tcPr marL="27432" marR="27432" marT="0" marB="0">
-                    <a:solidFill>
-                      <a:srgbClr val="FBE9E7"/>
+                            <a:srgbClr val="687386"/>
+                          </a:solidFill>
+                          <a:latin typeface="Arial"/>
+                        </a:rPr>
+                        <a:t>N/A</a:t>
+                      </a:r>
+                    </a:p>
+                  </a:txBody>
+                  <a:tcPr marL="27432" marR="27432" marT="0" marB="0">
+                    <a:solidFill>
+                      <a:srgbClr val="E9EDF2"/>
                     </a:solidFill>
                     <a:lnL w="9000" cap="flat" cmpd="sng" algn="ctr">
                       <a:solidFill>
@@ -17141,7 +17141,7 @@
                           </a:solidFill>
                           <a:latin typeface="Arial"/>
                         </a:rPr>
-                        <a:t>1.277</a:t>
+                        <a:t>0</a:t>
                       </a:r>
                     </a:p>
                   </a:txBody>
@@ -17231,17 +17231,17 @@
                       <a:r>
                         <a:rPr sz="1050" b="0">
                           <a:solidFill>
-                            <a:srgbClr val="D73527"/>
-                          </a:solidFill>
-                          <a:latin typeface="Arial"/>
-                        </a:rPr>
-                        <a:t>-97,3%</a:t>
-                      </a:r>
-                    </a:p>
-                  </a:txBody>
-                  <a:tcPr marL="27432" marR="27432" marT="0" marB="0">
-                    <a:solidFill>
-                      <a:srgbClr val="FBE9E7"/>
+                            <a:srgbClr val="687386"/>
+                          </a:solidFill>
+                          <a:latin typeface="Arial"/>
+                        </a:rPr>
+                        <a:t>N/A</a:t>
+                      </a:r>
+                    </a:p>
+                  </a:txBody>
+                  <a:tcPr marL="27432" marR="27432" marT="0" marB="0">
+                    <a:solidFill>
+                      <a:srgbClr val="E9EDF2"/>
                     </a:solidFill>
                     <a:lnL w="9000" cap="flat" cmpd="sng" algn="ctr">
                       <a:solidFill>
@@ -26907,7 +26907,7 @@
                 </a:solidFill>
                 <a:latin typeface="Arial"/>
               </a:rPr>
-              <a:t>2.146</a:t>
+              <a:t>2.152</a:t>
             </a:r>
           </a:p>
         </p:txBody>
@@ -27129,7 +27129,7 @@
                 </a:solidFill>
                 <a:latin typeface="Arial"/>
               </a:rPr>
-              <a:t>972</a:t>
+              <a:t>978</a:t>
             </a:r>
           </a:p>
         </p:txBody>
@@ -36938,7 +36938,7 @@
                           </a:solidFill>
                           <a:latin typeface="Arial"/>
                         </a:rPr>
-                        <a:t>JULIADI</a:t>
+                        <a:t>AI IFA HANIFAH</a:t>
                       </a:r>
                     </a:p>
                   </a:txBody>
@@ -37032,7 +37032,7 @@
                           </a:solidFill>
                           <a:latin typeface="Arial"/>
                         </a:rPr>
-                        <a:t>1</a:t>
+                        <a:t>2</a:t>
                       </a:r>
                     </a:p>
                   </a:txBody>
@@ -37126,7 +37126,7 @@
                           </a:solidFill>
                           <a:latin typeface="Arial"/>
                         </a:rPr>
-                        <a:t>-1,0</a:t>
+                        <a:t>-2,0</a:t>
                       </a:r>
                     </a:p>
                   </a:txBody>

</xml_diff>